<commit_message>
feat: perbarui pengalaman PT Telkom Indonesia menjadi Representative District Southern (Jul 2026 - Sekarang)
</commit_message>
<xml_diff>
--- a/public/downloads/Portofolio-Reihan-Mutaqin.pptx
+++ b/public/downloads/Portofolio-Reihan-Mutaqin.pptx
@@ -8477,7 +8477,7 @@
                 <a:ea typeface="Courier New" pitchFamily="34" charset="-122"/>
                 <a:cs typeface="Courier New" pitchFamily="34" charset="-120"/>
               </a:rPr>
-              <a:t>Nov 2025 — Sekarang</a:t>
+              <a:t>Jul 2026 — Sekarang</a:t>
             </a:r>
             <a:endParaRPr lang="en-US" sz="750" dirty="0"/>
           </a:p>
@@ -8516,7 +8516,7 @@
                 <a:ea typeface="Segoe UI" pitchFamily="34" charset="-122"/>
                 <a:cs typeface="Segoe UI" pitchFamily="34" charset="-120"/>
               </a:rPr>
-              <a:t>Agent</a:t>
+              <a:t>Representative District Southern</a:t>
             </a:r>
             <a:endParaRPr lang="en-US" sz="1100" dirty="0"/>
           </a:p>
@@ -8597,7 +8597,7 @@
                 <a:ea typeface="Segoe UI" pitchFamily="34" charset="-122"/>
                 <a:cs typeface="Segoe UI" pitchFamily="34" charset="-120"/>
               </a:rPr>
-              <a:t>Merekonsiliasi data jaringan dan layanan antara UIM dengan informasi pelanggan. Memantau order alur WOC, organic, C4, GDoc, dan ROC. Mengembangkan automated filtering tool untuk cleansing data.</a:t>
+              <a:t>Menjalankan perwakilan operasional, koordinasi layanan District Southern, monitoring performa jaringan, rekonsiliasi data pelanggan, dan eskalasi isu.</a:t>
             </a:r>
             <a:endParaRPr lang="en-US" sz="850" dirty="0"/>
           </a:p>
@@ -8676,7 +8676,7 @@
                 <a:ea typeface="Courier New" pitchFamily="34" charset="-122"/>
                 <a:cs typeface="Courier New" pitchFamily="34" charset="-120"/>
               </a:rPr>
-              <a:t>Jul — Des 2025</a:t>
+              <a:t>Nov 2025 — Jun 2026</a:t>
             </a:r>
             <a:endParaRPr lang="en-US" sz="750" dirty="0"/>
           </a:p>
@@ -8715,7 +8715,7 @@
                 <a:ea typeface="Segoe UI" pitchFamily="34" charset="-122"/>
                 <a:cs typeface="Segoe UI" pitchFamily="34" charset="-120"/>
               </a:rPr>
-              <a:t>Pengajar Informatika</a:t>
+              <a:t>Agent</a:t>
             </a:r>
             <a:endParaRPr lang="en-US" sz="1100" dirty="0"/>
           </a:p>
@@ -8754,7 +8754,7 @@
                 <a:ea typeface="Segoe UI" pitchFamily="34" charset="-122"/>
                 <a:cs typeface="Segoe UI" pitchFamily="34" charset="-120"/>
               </a:rPr>
-              <a:t>Ganesha Operation</a:t>
+              <a:t>PT Telkom Indonesia</a:t>
             </a:r>
             <a:endParaRPr lang="en-US" sz="900" dirty="0"/>
           </a:p>
@@ -8796,7 +8796,7 @@
                 <a:ea typeface="Segoe UI" pitchFamily="34" charset="-122"/>
                 <a:cs typeface="Segoe UI" pitchFamily="34" charset="-120"/>
               </a:rPr>
-              <a:t>Menyusun modul ajar, menyampaikan konsep informatika &amp; pemrograman, serta memfasilitasi sesi latihan praktik dan evaluasi pemahaman siswa.</a:t>
+              <a:t>Merekonsiliasi data jaringan &amp; layanan UIM, memantau order WOC/ROC, dan mengembangkan automated tools cleansing data operasional.</a:t>
             </a:r>
             <a:endParaRPr lang="en-US" sz="850" dirty="0"/>
           </a:p>
@@ -8855,7 +8855,7 @@
                 <a:ea typeface="Courier New" pitchFamily="34" charset="-122"/>
                 <a:cs typeface="Courier New" pitchFamily="34" charset="-120"/>
               </a:rPr>
-              <a:t>Okt 2022 — Sekarang</a:t>
+              <a:t>Jul — Des 2025</a:t>
             </a:r>
             <a:endParaRPr lang="en-US" sz="750" dirty="0"/>
           </a:p>
@@ -8894,7 +8894,7 @@
                 <a:ea typeface="Segoe UI" pitchFamily="34" charset="-122"/>
                 <a:cs typeface="Segoe UI" pitchFamily="34" charset="-120"/>
               </a:rPr>
-              <a:t>Freelance App, Game &amp; Web Developer</a:t>
+              <a:t>Pengajar Informatika</a:t>
             </a:r>
             <a:endParaRPr lang="en-US" sz="1100" dirty="0"/>
           </a:p>
@@ -8933,7 +8933,7 @@
                 <a:ea typeface="Segoe UI" pitchFamily="34" charset="-122"/>
                 <a:cs typeface="Segoe UI" pitchFamily="34" charset="-120"/>
               </a:rPr>
-              <a:t>Mandiri / Klien Profesional</a:t>
+              <a:t>Ganesha Operation</a:t>
             </a:r>
             <a:endParaRPr lang="en-US" sz="900" dirty="0"/>
           </a:p>
@@ -8975,7 +8975,7 @@
                 <a:ea typeface="Segoe UI" pitchFamily="34" charset="-122"/>
                 <a:cs typeface="Segoe UI" pitchFamily="34" charset="-120"/>
               </a:rPr>
-              <a:t>Mengembangkan platform AI, web tools, aplikasi AR berbasis Unity, game edukasi 3D/2D, hingga CMS berita &amp; e-commerce terintegrasi.</a:t>
+              <a:t>Menyusun modul ajar, menyampaikan konsep informatika &amp; pemrograman, serta memfasilitasi sesi latihan praktik dan evaluasi pemahaman siswa.</a:t>
             </a:r>
             <a:endParaRPr lang="en-US" sz="850" dirty="0"/>
           </a:p>
@@ -9054,7 +9054,7 @@
                 <a:ea typeface="Courier New" pitchFamily="34" charset="-122"/>
                 <a:cs typeface="Courier New" pitchFamily="34" charset="-120"/>
               </a:rPr>
-              <a:t>Feb — Mar 2024</a:t>
+              <a:t>Okt 2022 — Sekarang</a:t>
             </a:r>
             <a:endParaRPr lang="en-US" sz="750" dirty="0"/>
           </a:p>
@@ -9093,7 +9093,7 @@
                 <a:ea typeface="Segoe UI" pitchFamily="34" charset="-122"/>
                 <a:cs typeface="Segoe UI" pitchFamily="34" charset="-120"/>
               </a:rPr>
-              <a:t>Pengajar Magang</a:t>
+              <a:t>Freelance App, Game &amp; Web Developer</a:t>
             </a:r>
             <a:endParaRPr lang="en-US" sz="1100" dirty="0"/>
           </a:p>
@@ -9132,7 +9132,7 @@
                 <a:ea typeface="Segoe UI" pitchFamily="34" charset="-122"/>
                 <a:cs typeface="Segoe UI" pitchFamily="34" charset="-120"/>
               </a:rPr>
-              <a:t>SMKN 1 Pandeglang</a:t>
+              <a:t>Mandiri / Klien Profesional</a:t>
             </a:r>
             <a:endParaRPr lang="en-US" sz="900" dirty="0"/>
           </a:p>
@@ -9174,7 +9174,7 @@
                 <a:ea typeface="Segoe UI" pitchFamily="34" charset="-122"/>
                 <a:cs typeface="Segoe UI" pitchFamily="34" charset="-120"/>
               </a:rPr>
-              <a:t>Mengajar lebih dari 2 kelas bidang TKJ/Informatika, menyusun rancangan pembelajaran, dan membimbing praktikum perangkat keras &amp; jaringan.</a:t>
+              <a:t>Mengembangkan platform AI, web tools, aplikasi AR berbasis Unity, game edukasi 3D/2D, hingga CMS berita &amp; e-commerce terintegrasi.</a:t>
             </a:r>
             <a:endParaRPr lang="en-US" sz="850" dirty="0"/>
           </a:p>
@@ -9233,7 +9233,7 @@
                 <a:ea typeface="Courier New" pitchFamily="34" charset="-122"/>
                 <a:cs typeface="Courier New" pitchFamily="34" charset="-120"/>
               </a:rPr>
-              <a:t>Jul — Sep 2019</a:t>
+              <a:t>Feb — Mar 2024</a:t>
             </a:r>
             <a:endParaRPr lang="en-US" sz="750" dirty="0"/>
           </a:p>
@@ -9272,7 +9272,7 @@
                 <a:ea typeface="Segoe UI" pitchFamily="34" charset="-122"/>
                 <a:cs typeface="Segoe UI" pitchFamily="34" charset="-120"/>
               </a:rPr>
-              <a:t>Magang Divisi Media</a:t>
+              <a:t>Pengajar Magang</a:t>
             </a:r>
             <a:endParaRPr lang="en-US" sz="1100" dirty="0"/>
           </a:p>
@@ -9311,7 +9311,7 @@
                 <a:ea typeface="Segoe UI" pitchFamily="34" charset="-122"/>
                 <a:cs typeface="Segoe UI" pitchFamily="34" charset="-120"/>
               </a:rPr>
-              <a:t>Diskominfo Pandeglang</a:t>
+              <a:t>SMKN 1 Pandeglang</a:t>
             </a:r>
             <a:endParaRPr lang="en-US" sz="900" dirty="0"/>
           </a:p>
@@ -9353,6 +9353,185 @@
                 <a:ea typeface="Segoe UI" pitchFamily="34" charset="-122"/>
                 <a:cs typeface="Segoe UI" pitchFamily="34" charset="-120"/>
               </a:rPr>
+              <a:t>Mengajar lebih dari 2 kelas bidang TKJ/Informatika, menyusun rancangan pembelajaran, dan membimbing praktikum perangkat keras &amp; jaringan.</a:t>
+            </a:r>
+            <a:endParaRPr lang="en-US" sz="850" dirty="0"/>
+          </a:p>
+        </p:txBody>
+      </p:sp>
+      <p:sp>
+        <p:nvSpPr>
+          <p:cNvPr id="35" name="Shape 33"/>
+          <p:cNvSpPr/>
+          <p:nvPr/>
+        </p:nvSpPr>
+        <p:spPr>
+          <a:xfrm>
+            <a:off x="6309360" y="4919472"/>
+            <a:ext cx="128016" cy="128016"/>
+          </a:xfrm>
+          <a:prstGeom prst="ellipse">
+            <a:avLst/>
+          </a:prstGeom>
+          <a:solidFill>
+            <a:srgbClr val="E95D32"/>
+          </a:solidFill>
+          <a:ln/>
+        </p:spPr>
+      </p:sp>
+      <p:sp>
+        <p:nvSpPr>
+          <p:cNvPr id="36" name="Text 34"/>
+          <p:cNvSpPr/>
+          <p:nvPr/>
+        </p:nvSpPr>
+        <p:spPr>
+          <a:xfrm>
+            <a:off x="6537960" y="4754880"/>
+            <a:ext cx="5303520" cy="228600"/>
+          </a:xfrm>
+          <a:prstGeom prst="rect">
+            <a:avLst/>
+          </a:prstGeom>
+          <a:noFill/>
+          <a:ln/>
+        </p:spPr>
+        <p:txBody>
+          <a:bodyPr wrap="square" rtlCol="0" anchor="ctr"/>
+          <a:lstStyle/>
+          <a:p>
+            <a:pPr indent="0" marL="0">
+              <a:buNone/>
+            </a:pPr>
+            <a:r>
+              <a:rPr lang="en-US" sz="750" dirty="0">
+                <a:solidFill>
+                  <a:srgbClr val="655F57"/>
+                </a:solidFill>
+                <a:latin typeface="Courier New" pitchFamily="34" charset="0"/>
+                <a:ea typeface="Courier New" pitchFamily="34" charset="-122"/>
+                <a:cs typeface="Courier New" pitchFamily="34" charset="-120"/>
+              </a:rPr>
+              <a:t>Jul — Sep 2019</a:t>
+            </a:r>
+            <a:endParaRPr lang="en-US" sz="750" dirty="0"/>
+          </a:p>
+        </p:txBody>
+      </p:sp>
+      <p:sp>
+        <p:nvSpPr>
+          <p:cNvPr id="37" name="Text 35"/>
+          <p:cNvSpPr/>
+          <p:nvPr/>
+        </p:nvSpPr>
+        <p:spPr>
+          <a:xfrm>
+            <a:off x="6537960" y="4992624"/>
+            <a:ext cx="5303520" cy="274320"/>
+          </a:xfrm>
+          <a:prstGeom prst="rect">
+            <a:avLst/>
+          </a:prstGeom>
+          <a:noFill/>
+          <a:ln/>
+        </p:spPr>
+        <p:txBody>
+          <a:bodyPr wrap="square" rtlCol="0" anchor="ctr"/>
+          <a:lstStyle/>
+          <a:p>
+            <a:pPr indent="0" marL="0">
+              <a:buNone/>
+            </a:pPr>
+            <a:r>
+              <a:rPr lang="en-US" sz="1100" b="1" dirty="0">
+                <a:solidFill>
+                  <a:srgbClr val="FFFFFF"/>
+                </a:solidFill>
+                <a:latin typeface="Segoe UI" pitchFamily="34" charset="0"/>
+                <a:ea typeface="Segoe UI" pitchFamily="34" charset="-122"/>
+                <a:cs typeface="Segoe UI" pitchFamily="34" charset="-120"/>
+              </a:rPr>
+              <a:t>Magang Divisi Media</a:t>
+            </a:r>
+            <a:endParaRPr lang="en-US" sz="1100" dirty="0"/>
+          </a:p>
+        </p:txBody>
+      </p:sp>
+      <p:sp>
+        <p:nvSpPr>
+          <p:cNvPr id="38" name="Text 36"/>
+          <p:cNvSpPr/>
+          <p:nvPr/>
+        </p:nvSpPr>
+        <p:spPr>
+          <a:xfrm>
+            <a:off x="6537960" y="5276088"/>
+            <a:ext cx="5303520" cy="228600"/>
+          </a:xfrm>
+          <a:prstGeom prst="rect">
+            <a:avLst/>
+          </a:prstGeom>
+          <a:noFill/>
+          <a:ln/>
+        </p:spPr>
+        <p:txBody>
+          <a:bodyPr wrap="square" rtlCol="0" anchor="ctr"/>
+          <a:lstStyle/>
+          <a:p>
+            <a:pPr indent="0" marL="0">
+              <a:buNone/>
+            </a:pPr>
+            <a:r>
+              <a:rPr lang="en-US" sz="900" b="1" dirty="0">
+                <a:solidFill>
+                  <a:srgbClr val="E95D32"/>
+                </a:solidFill>
+                <a:latin typeface="Segoe UI" pitchFamily="34" charset="0"/>
+                <a:ea typeface="Segoe UI" pitchFamily="34" charset="-122"/>
+                <a:cs typeface="Segoe UI" pitchFamily="34" charset="-120"/>
+              </a:rPr>
+              <a:t>Diskominfo Pandeglang</a:t>
+            </a:r>
+            <a:endParaRPr lang="en-US" sz="900" dirty="0"/>
+          </a:p>
+        </p:txBody>
+      </p:sp>
+      <p:sp>
+        <p:nvSpPr>
+          <p:cNvPr id="39" name="Text 37"/>
+          <p:cNvSpPr/>
+          <p:nvPr/>
+        </p:nvSpPr>
+        <p:spPr>
+          <a:xfrm>
+            <a:off x="6537960" y="5522976"/>
+            <a:ext cx="5303520" cy="640080"/>
+          </a:xfrm>
+          <a:prstGeom prst="rect">
+            <a:avLst/>
+          </a:prstGeom>
+          <a:noFill/>
+          <a:ln/>
+        </p:spPr>
+        <p:txBody>
+          <a:bodyPr wrap="square" rtlCol="0" anchor="ctr"/>
+          <a:lstStyle/>
+          <a:p>
+            <a:pPr indent="0" marL="0">
+              <a:lnSpc>
+                <a:spcPct val="130000"/>
+              </a:lnSpc>
+              <a:buNone/>
+            </a:pPr>
+            <a:r>
+              <a:rPr lang="en-US" sz="850" dirty="0">
+                <a:solidFill>
+                  <a:srgbClr val="A09890"/>
+                </a:solidFill>
+                <a:latin typeface="Segoe UI" pitchFamily="34" charset="0"/>
+                <a:ea typeface="Segoe UI" pitchFamily="34" charset="-122"/>
+                <a:cs typeface="Segoe UI" pitchFamily="34" charset="-120"/>
+              </a:rPr>
               <a:t>Mengelola situs dinas, membantu pemantauan keamanan wilayah di Gedung Pintar, dan mendokumentasikan kegiatan dinas.</a:t>
             </a:r>
             <a:endParaRPr lang="en-US" sz="850" dirty="0"/>
@@ -9361,7 +9540,7 @@
       </p:sp>
       <p:sp>
         <p:nvSpPr>
-          <p:cNvPr id="35" name="Text 33"/>
+          <p:cNvPr id="40" name="Text 38"/>
           <p:cNvSpPr/>
           <p:nvPr/>
         </p:nvSpPr>

</xml_diff>

<commit_message>
fix: kurangi padding gap section profil dan pindahkan info TOEFL ke Universitas Bina Bangsa
</commit_message>
<xml_diff>
--- a/public/downloads/Portofolio-Reihan-Mutaqin.pptx
+++ b/public/downloads/Portofolio-Reihan-Mutaqin.pptx
@@ -5306,7 +5306,7 @@
                 <a:ea typeface="Segoe UI" pitchFamily="34" charset="-122"/>
                 <a:cs typeface="Segoe UI" pitchFamily="34" charset="-120"/>
               </a:rPr>
-              <a:t>Pendidikan Tinggi</a:t>
+              <a:t>Pendidikan Tinggi &amp; Bahasa</a:t>
             </a:r>
             <a:endParaRPr lang="en-US" sz="750" dirty="0"/>
           </a:p>
@@ -5426,7 +5426,7 @@
                 <a:ea typeface="Segoe UI" pitchFamily="34" charset="-122"/>
                 <a:cs typeface="Segoe UI" pitchFamily="34" charset="-120"/>
               </a:rPr>
-              <a:t>★ IPK 3,96 / 4,00 — Lulusan Terbaik Program Studi 2024</a:t>
+              <a:t>★ IPK 3,96 / 4,00 (Lulusan Terbaik) · TOEFL Score 550</a:t>
             </a:r>
             <a:endParaRPr lang="en-US" sz="950" dirty="0"/>
           </a:p>
@@ -5630,7 +5630,7 @@
                 <a:ea typeface="Segoe UI" pitchFamily="34" charset="-122"/>
                 <a:cs typeface="Segoe UI" pitchFamily="34" charset="-120"/>
               </a:rPr>
-              <a:t>✓ Dasar kuat arsitektur komputer, jaringan &amp; sistem operasi</a:t>
+              <a:t>✓ Dasar kuat arsitektur komputer, hardware, jaringan &amp; troubleshooting</a:t>
             </a:r>
             <a:endParaRPr lang="en-US" sz="950" dirty="0"/>
           </a:p>
@@ -5918,7 +5918,7 @@
                 <a:ea typeface="Segoe UI" pitchFamily="34" charset="-122"/>
                 <a:cs typeface="Segoe UI" pitchFamily="34" charset="-120"/>
               </a:rPr>
-              <a:t>Kontribusi &amp; Bahasa</a:t>
+              <a:t>Kontribusi Komunitas</a:t>
             </a:r>
             <a:endParaRPr lang="en-US" sz="750" dirty="0"/>
           </a:p>
@@ -5957,7 +5957,7 @@
                 <a:ea typeface="Segoe UI" pitchFamily="34" charset="-122"/>
                 <a:cs typeface="Segoe UI" pitchFamily="34" charset="-120"/>
               </a:rPr>
-              <a:t>Inovasi Teknologi Pendidikan ID &amp; TOEFL</a:t>
+              <a:t>Inovasi Teknologi Pendidikan ID</a:t>
             </a:r>
             <a:endParaRPr lang="en-US" sz="1300" dirty="0"/>
           </a:p>
@@ -6038,7 +6038,7 @@
                 <a:ea typeface="Segoe UI" pitchFamily="34" charset="-122"/>
                 <a:cs typeface="Segoe UI" pitchFamily="34" charset="-120"/>
               </a:rPr>
-              <a:t>TOEFL Score 550 · Kemahiran Bahasa Inggris Profesional</a:t>
+              <a:t>Pengembangan aplikasi digital dan pengelolaan e-learning</a:t>
             </a:r>
             <a:endParaRPr lang="en-US" sz="950" dirty="0"/>
           </a:p>

</xml_diff>

<commit_message>
fix: perbarui link HR Portal & Management System menjadi https://hr.reihan.online/
</commit_message>
<xml_diff>
--- a/public/downloads/Portofolio-Reihan-Mutaqin.pptx
+++ b/public/downloads/Portofolio-Reihan-Mutaqin.pptx
@@ -3905,7 +3905,7 @@
                 <a:ea typeface="Segoe UI" pitchFamily="34" charset="-122"/>
                 <a:cs typeface="Segoe UI" pitchFamily="34" charset="-120"/>
               </a:rPr>
-              <a:t>Web CMS, E-Commerce &amp; HR System</a:t>
+              <a:t>Digital Invitation &amp; Web CMS Portal</a:t>
             </a:r>
             <a:endParaRPr lang="en-US" sz="900" dirty="0"/>
           </a:p>
@@ -4017,7 +4017,7 @@
                 <a:ea typeface="Courier New" pitchFamily="34" charset="-122"/>
                 <a:cs typeface="Courier New" pitchFamily="34" charset="-120"/>
               </a:rPr>
-              <a:t>2024</a:t>
+              <a:t>2026</a:t>
             </a:r>
             <a:endParaRPr lang="en-US" sz="800" dirty="0"/>
           </a:p>
@@ -4081,7 +4081,7 @@
                 <a:ea typeface="Segoe UI" pitchFamily="34" charset="-122"/>
                 <a:cs typeface="Segoe UI" pitchFamily="34" charset="-120"/>
               </a:rPr>
-              <a:t>Portal Berita</a:t>
+              <a:t>Digital Invitation</a:t>
             </a:r>
             <a:endParaRPr lang="en-US" sz="700" dirty="0"/>
           </a:p>
@@ -4123,7 +4123,7 @@
                 <a:ea typeface="Segoe UI" pitchFamily="34" charset="-122"/>
                 <a:cs typeface="Segoe UI" pitchFamily="34" charset="-120"/>
               </a:rPr>
-              <a:t>42 Berita Kita</a:t>
+              <a:t>The Wedding of Sheva &amp; Angel</a:t>
             </a:r>
             <a:endParaRPr lang="en-US" sz="1300" dirty="0"/>
           </a:p>
@@ -4165,7 +4165,7 @@
                 <a:ea typeface="Segoe UI" pitchFamily="34" charset="-122"/>
                 <a:cs typeface="Segoe UI" pitchFamily="34" charset="-120"/>
               </a:rPr>
-              <a:t>Portal berita web responsif dengan manajemen konten dinamis, sistem kategori multi-level, panel administrasi redaksi, dan integrasi database untuk publikasi artikel real-time.</a:t>
+              <a:t>Platform undangan pernikahan digital interaktif dan responsif dengan buku tamu digital, amplop digital/rekening, reservasi kehadiran, background music, dan animasi interaktif.</a:t>
             </a:r>
             <a:endParaRPr lang="en-US" sz="880" dirty="0"/>
           </a:p>
@@ -4180,7 +4180,7 @@
         <p:spPr>
           <a:xfrm>
             <a:off x="548640" y="5532120"/>
-            <a:ext cx="1062533" cy="246888"/>
+            <a:ext cx="1400861" cy="246888"/>
           </a:xfrm>
           <a:prstGeom prst="rect">
             <a:avLst/>
@@ -4205,7 +4205,7 @@
         <p:spPr>
           <a:xfrm>
             <a:off x="548640" y="5532120"/>
-            <a:ext cx="1062533" cy="246888"/>
+            <a:ext cx="1400861" cy="246888"/>
           </a:xfrm>
           <a:prstGeom prst="rect">
             <a:avLst/>
@@ -4229,7 +4229,7 @@
                 <a:ea typeface="Segoe UI" pitchFamily="34" charset="-122"/>
                 <a:cs typeface="Segoe UI" pitchFamily="34" charset="-120"/>
               </a:rPr>
-              <a:t>Web Fullstack</a:t>
+              <a:t>Digital Invitation</a:t>
             </a:r>
             <a:endParaRPr lang="en-US" sz="750" dirty="0"/>
           </a:p>
@@ -4243,8 +4243,8 @@
         </p:nvSpPr>
         <p:spPr>
           <a:xfrm>
-            <a:off x="1702613" y="5532120"/>
-            <a:ext cx="927202" cy="246888"/>
+            <a:off x="2040941" y="5532120"/>
+            <a:ext cx="1197864" cy="246888"/>
           </a:xfrm>
           <a:prstGeom prst="rect">
             <a:avLst/>
@@ -4268,8 +4268,8 @@
         </p:nvSpPr>
         <p:spPr>
           <a:xfrm>
-            <a:off x="1702613" y="5532120"/>
-            <a:ext cx="927202" cy="246888"/>
+            <a:off x="2040941" y="5532120"/>
+            <a:ext cx="1197864" cy="246888"/>
           </a:xfrm>
           <a:prstGeom prst="rect">
             <a:avLst/>
@@ -4293,7 +4293,7 @@
                 <a:ea typeface="Segoe UI" pitchFamily="34" charset="-122"/>
                 <a:cs typeface="Segoe UI" pitchFamily="34" charset="-120"/>
               </a:rPr>
-              <a:t>PHP / MySQL</a:t>
+              <a:t>Interactive Web</a:t>
             </a:r>
             <a:endParaRPr lang="en-US" sz="750" dirty="0"/>
           </a:p>
@@ -4307,8 +4307,8 @@
         </p:nvSpPr>
         <p:spPr>
           <a:xfrm>
-            <a:off x="2721254" y="5532120"/>
-            <a:ext cx="1062533" cy="246888"/>
+            <a:off x="3330245" y="5532120"/>
+            <a:ext cx="521208" cy="246888"/>
           </a:xfrm>
           <a:prstGeom prst="rect">
             <a:avLst/>
@@ -4332,8 +4332,8 @@
         </p:nvSpPr>
         <p:spPr>
           <a:xfrm>
-            <a:off x="2721254" y="5532120"/>
-            <a:ext cx="1062533" cy="246888"/>
+            <a:off x="3330245" y="5532120"/>
+            <a:ext cx="521208" cy="246888"/>
           </a:xfrm>
           <a:prstGeom prst="rect">
             <a:avLst/>
@@ -4357,7 +4357,7 @@
                 <a:ea typeface="Segoe UI" pitchFamily="34" charset="-122"/>
                 <a:cs typeface="Segoe UI" pitchFamily="34" charset="-120"/>
               </a:rPr>
-              <a:t>CMS Dashboard</a:t>
+              <a:t>UI/UX</a:t>
             </a:r>
             <a:endParaRPr lang="en-US" sz="750" dirty="0"/>
           </a:p>
@@ -4371,8 +4371,8 @@
         </p:nvSpPr>
         <p:spPr>
           <a:xfrm>
-            <a:off x="3875227" y="5532120"/>
-            <a:ext cx="994867" cy="246888"/>
+            <a:off x="3942893" y="5532120"/>
+            <a:ext cx="791870" cy="246888"/>
           </a:xfrm>
           <a:prstGeom prst="rect">
             <a:avLst/>
@@ -4396,8 +4396,8 @@
         </p:nvSpPr>
         <p:spPr>
           <a:xfrm>
-            <a:off x="3875227" y="5532120"/>
-            <a:ext cx="994867" cy="246888"/>
+            <a:off x="3942893" y="5532120"/>
+            <a:ext cx="791870" cy="246888"/>
           </a:xfrm>
           <a:prstGeom prst="rect">
             <a:avLst/>
@@ -4421,7 +4421,7 @@
                 <a:ea typeface="Segoe UI" pitchFamily="34" charset="-122"/>
                 <a:cs typeface="Segoe UI" pitchFamily="34" charset="-120"/>
               </a:rPr>
-              <a:t>SEO Friendly</a:t>
+              <a:t>Animation</a:t>
             </a:r>
             <a:endParaRPr lang="en-US" sz="750" dirty="0"/>
           </a:p>
@@ -4469,7 +4469,7 @@
                   </a:extLst>
                 </a:hlinkClick>
               </a:rPr>
-              <a:t>🔗 berita.42web.io</a:t>
+              <a:t>🔗 shevaangel.vercel.app</a:t>
             </a:r>
             <a:endParaRPr lang="en-US" sz="800" dirty="0"/>
           </a:p>
@@ -4581,7 +4581,7 @@
                 <a:ea typeface="Courier New" pitchFamily="34" charset="-122"/>
                 <a:cs typeface="Courier New" pitchFamily="34" charset="-120"/>
               </a:rPr>
-              <a:t>2023</a:t>
+              <a:t>2024</a:t>
             </a:r>
             <a:endParaRPr lang="en-US" sz="800" dirty="0"/>
           </a:p>
@@ -4645,7 +4645,7 @@
                 <a:ea typeface="Segoe UI" pitchFamily="34" charset="-122"/>
                 <a:cs typeface="Segoe UI" pitchFamily="34" charset="-120"/>
               </a:rPr>
-              <a:t>Toko Online</a:t>
+              <a:t>Portal Berita</a:t>
             </a:r>
             <a:endParaRPr lang="en-US" sz="700" dirty="0"/>
           </a:p>
@@ -4687,7 +4687,7 @@
                 <a:ea typeface="Segoe UI" pitchFamily="34" charset="-122"/>
                 <a:cs typeface="Segoe UI" pitchFamily="34" charset="-120"/>
               </a:rPr>
-              <a:t>Platform E-Commerce &amp; Katalog Produk</a:t>
+              <a:t>42 Berita Kita</a:t>
             </a:r>
             <a:endParaRPr lang="en-US" sz="1300" dirty="0"/>
           </a:p>
@@ -4729,7 +4729,7 @@
                 <a:ea typeface="Segoe UI" pitchFamily="34" charset="-122"/>
                 <a:cs typeface="Segoe UI" pitchFamily="34" charset="-120"/>
               </a:rPr>
-              <a:t>Sistem penjualan digital dengan katalog interaktif, filter kategori, keranjang belanja, checkout notifikasi WhatsApp, serta dashboard admin untuk pengelolaan stok dan pesanan.</a:t>
+              <a:t>Portal berita web responsif dengan manajemen konten dinamis, sistem kategori multi-level, panel administrasi redaksi, dan integrasi database untuk publikasi artikel real-time.</a:t>
             </a:r>
             <a:endParaRPr lang="en-US" sz="880" dirty="0"/>
           </a:p>
@@ -4744,7 +4744,7 @@
         <p:spPr>
           <a:xfrm>
             <a:off x="6583680" y="5532120"/>
-            <a:ext cx="1333195" cy="246888"/>
+            <a:ext cx="1062533" cy="246888"/>
           </a:xfrm>
           <a:prstGeom prst="rect">
             <a:avLst/>
@@ -4769,7 +4769,7 @@
         <p:spPr>
           <a:xfrm>
             <a:off x="6583680" y="5532120"/>
-            <a:ext cx="1333195" cy="246888"/>
+            <a:ext cx="1062533" cy="246888"/>
           </a:xfrm>
           <a:prstGeom prst="rect">
             <a:avLst/>
@@ -4793,7 +4793,7 @@
                 <a:ea typeface="Segoe UI" pitchFamily="34" charset="-122"/>
                 <a:cs typeface="Segoe UI" pitchFamily="34" charset="-120"/>
               </a:rPr>
-              <a:t>E-Commerce Engine</a:t>
+              <a:t>Web Fullstack</a:t>
             </a:r>
             <a:endParaRPr lang="en-US" sz="750" dirty="0"/>
           </a:p>
@@ -4807,8 +4807,8 @@
         </p:nvSpPr>
         <p:spPr>
           <a:xfrm>
-            <a:off x="8008315" y="5532120"/>
-            <a:ext cx="1197864" cy="246888"/>
+            <a:off x="7737653" y="5532120"/>
+            <a:ext cx="927202" cy="246888"/>
           </a:xfrm>
           <a:prstGeom prst="rect">
             <a:avLst/>
@@ -4832,8 +4832,8 @@
         </p:nvSpPr>
         <p:spPr>
           <a:xfrm>
-            <a:off x="8008315" y="5532120"/>
-            <a:ext cx="1197864" cy="246888"/>
+            <a:off x="7737653" y="5532120"/>
+            <a:ext cx="927202" cy="246888"/>
           </a:xfrm>
           <a:prstGeom prst="rect">
             <a:avLst/>
@@ -4857,7 +4857,7 @@
                 <a:ea typeface="Segoe UI" pitchFamily="34" charset="-122"/>
                 <a:cs typeface="Segoe UI" pitchFamily="34" charset="-120"/>
               </a:rPr>
-              <a:t>Cart &amp; Checkout</a:t>
+              <a:t>PHP / MySQL</a:t>
             </a:r>
             <a:endParaRPr lang="en-US" sz="750" dirty="0"/>
           </a:p>
@@ -4871,8 +4871,8 @@
         </p:nvSpPr>
         <p:spPr>
           <a:xfrm>
-            <a:off x="9297619" y="5532120"/>
-            <a:ext cx="1265530" cy="246888"/>
+            <a:off x="8756294" y="5532120"/>
+            <a:ext cx="1062533" cy="246888"/>
           </a:xfrm>
           <a:prstGeom prst="rect">
             <a:avLst/>
@@ -4896,8 +4896,8 @@
         </p:nvSpPr>
         <p:spPr>
           <a:xfrm>
-            <a:off x="9297619" y="5532120"/>
-            <a:ext cx="1265530" cy="246888"/>
+            <a:off x="8756294" y="5532120"/>
+            <a:ext cx="1062533" cy="246888"/>
           </a:xfrm>
           <a:prstGeom prst="rect">
             <a:avLst/>
@@ -4921,7 +4921,7 @@
                 <a:ea typeface="Segoe UI" pitchFamily="34" charset="-122"/>
                 <a:cs typeface="Segoe UI" pitchFamily="34" charset="-120"/>
               </a:rPr>
-              <a:t>Stock Management</a:t>
+              <a:t>CMS Dashboard</a:t>
             </a:r>
             <a:endParaRPr lang="en-US" sz="750" dirty="0"/>
           </a:p>
@@ -4935,8 +4935,8 @@
         </p:nvSpPr>
         <p:spPr>
           <a:xfrm>
-            <a:off x="10654589" y="5532120"/>
-            <a:ext cx="521208" cy="246888"/>
+            <a:off x="9910267" y="5532120"/>
+            <a:ext cx="994867" cy="246888"/>
           </a:xfrm>
           <a:prstGeom prst="rect">
             <a:avLst/>
@@ -4960,8 +4960,8 @@
         </p:nvSpPr>
         <p:spPr>
           <a:xfrm>
-            <a:off x="10654589" y="5532120"/>
-            <a:ext cx="521208" cy="246888"/>
+            <a:off x="9910267" y="5532120"/>
+            <a:ext cx="994867" cy="246888"/>
           </a:xfrm>
           <a:prstGeom prst="rect">
             <a:avLst/>
@@ -4985,7 +4985,7 @@
                 <a:ea typeface="Segoe UI" pitchFamily="34" charset="-122"/>
                 <a:cs typeface="Segoe UI" pitchFamily="34" charset="-120"/>
               </a:rPr>
-              <a:t>UI/UX</a:t>
+              <a:t>SEO Friendly</a:t>
             </a:r>
             <a:endParaRPr lang="en-US" sz="750" dirty="0"/>
           </a:p>
@@ -4993,7 +4993,55 @@
       </p:sp>
       <p:sp>
         <p:nvSpPr>
-          <p:cNvPr id="39" name="Text 35"/>
+          <p:cNvPr id="39" name="Text 35">
+            <a:hlinkClick r:id="rId4" tooltip=""/>
+          </p:cNvPr>
+          <p:cNvSpPr/>
+          <p:nvPr/>
+        </p:nvSpPr>
+        <p:spPr>
+          <a:xfrm>
+            <a:off x="6583680" y="6309360"/>
+            <a:ext cx="5120640" cy="228600"/>
+          </a:xfrm>
+          <a:prstGeom prst="rect">
+            <a:avLst/>
+          </a:prstGeom>
+          <a:noFill/>
+          <a:ln/>
+        </p:spPr>
+        <p:txBody>
+          <a:bodyPr wrap="square" rtlCol="0" anchor="ctr"/>
+          <a:lstStyle/>
+          <a:p>
+            <a:pPr indent="0" marL="0">
+              <a:buNone/>
+            </a:pPr>
+            <a:r>
+              <a:rPr lang="en-US" sz="800" u="sng" dirty="0">
+                <a:solidFill>
+                  <a:srgbClr val="F2C94C"/>
+                </a:solidFill>
+                <a:latin typeface="Segoe UI" pitchFamily="34" charset="0"/>
+                <a:ea typeface="Segoe UI" pitchFamily="34" charset="-122"/>
+                <a:cs typeface="Segoe UI" pitchFamily="34" charset="-120"/>
+                <a:hlinkClick r:id="rId4" invalidUrl="" action="" tgtFrame="" tooltip="" history="1" highlightClick="0" endSnd="0">
+                  <a:extLst>
+                    <a:ext uri="{A12FA001-AC4F-418D-AE19-62706E023703}">
+                      <ahyp:hlinkClr xmlns:ahyp="http://schemas.microsoft.com/office/drawing/2018/hyperlinkcolor" val="tx"/>
+                    </a:ext>
+                  </a:extLst>
+                </a:hlinkClick>
+              </a:rPr>
+              <a:t>🔗 berita.42web.io</a:t>
+            </a:r>
+            <a:endParaRPr lang="en-US" sz="800" dirty="0"/>
+          </a:p>
+        </p:txBody>
+      </p:sp>
+      <p:sp>
+        <p:nvSpPr>
+          <p:cNvPr id="40" name="Text 36"/>
           <p:cNvSpPr/>
           <p:nvPr/>
         </p:nvSpPr>
@@ -15893,7 +15941,7 @@
                 <a:ea typeface="Segoe UI" pitchFamily="34" charset="-122"/>
                 <a:cs typeface="Segoe UI" pitchFamily="34" charset="-120"/>
               </a:rPr>
-              <a:t>Healthcare Enterprise &amp; Digital Invitation</a:t>
+              <a:t>Healthcare Enterprise &amp; HR Management System</a:t>
             </a:r>
             <a:endParaRPr lang="en-US" sz="900" dirty="0"/>
           </a:p>
@@ -16633,7 +16681,7 @@
                 <a:ea typeface="Segoe UI" pitchFamily="34" charset="-122"/>
                 <a:cs typeface="Segoe UI" pitchFamily="34" charset="-120"/>
               </a:rPr>
-              <a:t>Digital Invitation</a:t>
+              <a:t>HR Tech &amp; Management</a:t>
             </a:r>
             <a:endParaRPr lang="en-US" sz="700" dirty="0"/>
           </a:p>
@@ -16675,7 +16723,7 @@
                 <a:ea typeface="Segoe UI" pitchFamily="34" charset="-122"/>
                 <a:cs typeface="Segoe UI" pitchFamily="34" charset="-120"/>
               </a:rPr>
-              <a:t>The Wedding of Sheva &amp; Angel</a:t>
+              <a:t>HR Portal &amp; Management System</a:t>
             </a:r>
             <a:endParaRPr lang="en-US" sz="1300" dirty="0"/>
           </a:p>
@@ -16717,7 +16765,7 @@
                 <a:ea typeface="Segoe UI" pitchFamily="34" charset="-122"/>
                 <a:cs typeface="Segoe UI" pitchFamily="34" charset="-120"/>
               </a:rPr>
-              <a:t>Platform undangan pernikahan digital interaktif dan responsif dengan buku tamu digital, amplop digital/rekening, reservasi kehadiran, background music, dan animasi interaktif.</a:t>
+              <a:t>Platform HRIS dan manajemen SDM modern dengan data karyawan terpusat, rekapitulasi absensi/kehadiran, pengajuan izin/cuti, dan reporting performa terpadu.</a:t>
             </a:r>
             <a:endParaRPr lang="en-US" sz="880" dirty="0"/>
           </a:p>
@@ -16732,7 +16780,7 @@
         <p:spPr>
           <a:xfrm>
             <a:off x="6583680" y="5532120"/>
-            <a:ext cx="1400861" cy="246888"/>
+            <a:ext cx="453542" cy="246888"/>
           </a:xfrm>
           <a:prstGeom prst="rect">
             <a:avLst/>
@@ -16757,7 +16805,7 @@
         <p:spPr>
           <a:xfrm>
             <a:off x="6583680" y="5532120"/>
-            <a:ext cx="1400861" cy="246888"/>
+            <a:ext cx="453542" cy="246888"/>
           </a:xfrm>
           <a:prstGeom prst="rect">
             <a:avLst/>
@@ -16781,7 +16829,7 @@
                 <a:ea typeface="Segoe UI" pitchFamily="34" charset="-122"/>
                 <a:cs typeface="Segoe UI" pitchFamily="34" charset="-120"/>
               </a:rPr>
-              <a:t>Digital Invitation</a:t>
+              <a:t>HRIS</a:t>
             </a:r>
             <a:endParaRPr lang="en-US" sz="750" dirty="0"/>
           </a:p>
@@ -16795,8 +16843,8 @@
         </p:nvSpPr>
         <p:spPr>
           <a:xfrm>
-            <a:off x="8075981" y="5532120"/>
-            <a:ext cx="1197864" cy="246888"/>
+            <a:off x="7128662" y="5532120"/>
+            <a:ext cx="1130198" cy="246888"/>
           </a:xfrm>
           <a:prstGeom prst="rect">
             <a:avLst/>
@@ -16820,8 +16868,8 @@
         </p:nvSpPr>
         <p:spPr>
           <a:xfrm>
-            <a:off x="8075981" y="5532120"/>
-            <a:ext cx="1197864" cy="246888"/>
+            <a:off x="7128662" y="5532120"/>
+            <a:ext cx="1130198" cy="246888"/>
           </a:xfrm>
           <a:prstGeom prst="rect">
             <a:avLst/>
@@ -16845,7 +16893,7 @@
                 <a:ea typeface="Segoe UI" pitchFamily="34" charset="-122"/>
                 <a:cs typeface="Segoe UI" pitchFamily="34" charset="-120"/>
               </a:rPr>
-              <a:t>Interactive Web</a:t>
+              <a:t>Enterprise Web</a:t>
             </a:r>
             <a:endParaRPr lang="en-US" sz="750" dirty="0"/>
           </a:p>
@@ -16859,8 +16907,8 @@
         </p:nvSpPr>
         <p:spPr>
           <a:xfrm>
-            <a:off x="9365285" y="5532120"/>
-            <a:ext cx="521208" cy="246888"/>
+            <a:off x="8350301" y="5532120"/>
+            <a:ext cx="791870" cy="246888"/>
           </a:xfrm>
           <a:prstGeom prst="rect">
             <a:avLst/>
@@ -16884,8 +16932,8 @@
         </p:nvSpPr>
         <p:spPr>
           <a:xfrm>
-            <a:off x="9365285" y="5532120"/>
-            <a:ext cx="521208" cy="246888"/>
+            <a:off x="8350301" y="5532120"/>
+            <a:ext cx="791870" cy="246888"/>
           </a:xfrm>
           <a:prstGeom prst="rect">
             <a:avLst/>
@@ -16909,7 +16957,7 @@
                 <a:ea typeface="Segoe UI" pitchFamily="34" charset="-122"/>
                 <a:cs typeface="Segoe UI" pitchFamily="34" charset="-120"/>
               </a:rPr>
-              <a:t>UI/UX</a:t>
+              <a:t>Dashboard</a:t>
             </a:r>
             <a:endParaRPr lang="en-US" sz="750" dirty="0"/>
           </a:p>
@@ -16923,8 +16971,8 @@
         </p:nvSpPr>
         <p:spPr>
           <a:xfrm>
-            <a:off x="9977933" y="5532120"/>
-            <a:ext cx="791870" cy="246888"/>
+            <a:off x="9233611" y="5532120"/>
+            <a:ext cx="859536" cy="246888"/>
           </a:xfrm>
           <a:prstGeom prst="rect">
             <a:avLst/>
@@ -16948,8 +16996,8 @@
         </p:nvSpPr>
         <p:spPr>
           <a:xfrm>
-            <a:off x="9977933" y="5532120"/>
-            <a:ext cx="791870" cy="246888"/>
+            <a:off x="9233611" y="5532120"/>
+            <a:ext cx="859536" cy="246888"/>
           </a:xfrm>
           <a:prstGeom prst="rect">
             <a:avLst/>
@@ -16973,7 +17021,7 @@
                 <a:ea typeface="Segoe UI" pitchFamily="34" charset="-122"/>
                 <a:cs typeface="Segoe UI" pitchFamily="34" charset="-120"/>
               </a:rPr>
-              <a:t>Animation</a:t>
+              <a:t>Management</a:t>
             </a:r>
             <a:endParaRPr lang="en-US" sz="750" dirty="0"/>
           </a:p>
@@ -17021,7 +17069,7 @@
                   </a:extLst>
                 </a:hlinkClick>
               </a:rPr>
-              <a:t>🔗 shevaangel.vercel.app</a:t>
+              <a:t>🔗 hr.reihan.online</a:t>
             </a:r>
             <a:endParaRPr lang="en-US" sz="800" dirty="0"/>
           </a:p>

</xml_diff>

<commit_message>
feat: alihkan Mari Bicara ke Telegram @Rei219 dan tambahkan ikon Telegram di kontak & footer
</commit_message>
<xml_diff>
--- a/public/downloads/Portofolio-Reihan-Mutaqin.pptx
+++ b/public/downloads/Portofolio-Reihan-Mutaqin.pptx
@@ -2228,7 +2228,7 @@
                 <a:ea typeface="Segoe UI" pitchFamily="34" charset="-122"/>
                 <a:cs typeface="Segoe UI" pitchFamily="34" charset="-120"/>
               </a:rPr>
-              <a:t>✉  reyhanmutakin1@gmail.com</a:t>
+              <a:t>✈  t.me/Rei219 (@Rei219)</a:t>
             </a:r>
             <a:endParaRPr lang="en-US" sz="950" dirty="0"/>
           </a:p>
@@ -2267,7 +2267,7 @@
                 <a:ea typeface="Segoe UI" pitchFamily="34" charset="-122"/>
                 <a:cs typeface="Segoe UI" pitchFamily="34" charset="-120"/>
               </a:rPr>
-              <a:t>📞  +62 821 1103 9958</a:t>
+              <a:t>✉  reyhanmutakin1@gmail.com</a:t>
             </a:r>
             <a:endParaRPr lang="en-US" sz="950" dirty="0"/>
           </a:p>
@@ -2306,7 +2306,7 @@
                 <a:ea typeface="Segoe UI" pitchFamily="34" charset="-122"/>
                 <a:cs typeface="Segoe UI" pitchFamily="34" charset="-120"/>
               </a:rPr>
-              <a:t>📍  Pandeglang, Banten, Indonesia</a:t>
+              <a:t>📞  +62 821 1103 9958</a:t>
             </a:r>
             <a:endParaRPr lang="en-US" sz="950" dirty="0"/>
           </a:p>
@@ -2345,7 +2345,7 @@
                 <a:ea typeface="Segoe UI" pitchFamily="34" charset="-122"/>
                 <a:cs typeface="Segoe UI" pitchFamily="34" charset="-120"/>
               </a:rPr>
-              <a:t>🔗  github.com/ReihanMutaqin</a:t>
+              <a:t>📍  Pandeglang, Banten, Indonesia</a:t>
             </a:r>
             <a:endParaRPr lang="en-US" sz="950" dirty="0"/>
           </a:p>
@@ -2384,7 +2384,7 @@
                 <a:ea typeface="Segoe UI" pitchFamily="34" charset="-122"/>
                 <a:cs typeface="Segoe UI" pitchFamily="34" charset="-120"/>
               </a:rPr>
-              <a:t>🔗  linkedin.com/in/reihan-mutaqin-351169201</a:t>
+              <a:t>🔗  github.com/ReihanMutaqin</a:t>
             </a:r>
             <a:endParaRPr lang="en-US" sz="950" dirty="0"/>
           </a:p>
@@ -2423,6 +2423,45 @@
                 <a:ea typeface="Segoe UI" pitchFamily="34" charset="-122"/>
                 <a:cs typeface="Segoe UI" pitchFamily="34" charset="-120"/>
               </a:rPr>
+              <a:t>🔗  linkedin.com/in/reihan-mutaqin-351169201</a:t>
+            </a:r>
+            <a:endParaRPr lang="en-US" sz="950" dirty="0"/>
+          </a:p>
+        </p:txBody>
+      </p:sp>
+      <p:sp>
+        <p:nvSpPr>
+          <p:cNvPr id="16" name="Text 14"/>
+          <p:cNvSpPr/>
+          <p:nvPr/>
+        </p:nvSpPr>
+        <p:spPr>
+          <a:xfrm>
+            <a:off x="457200" y="6135624"/>
+            <a:ext cx="6217920" cy="292608"/>
+          </a:xfrm>
+          <a:prstGeom prst="rect">
+            <a:avLst/>
+          </a:prstGeom>
+          <a:noFill/>
+          <a:ln/>
+        </p:spPr>
+        <p:txBody>
+          <a:bodyPr wrap="square" rtlCol="0" anchor="ctr"/>
+          <a:lstStyle/>
+          <a:p>
+            <a:pPr indent="0" marL="0">
+              <a:buNone/>
+            </a:pPr>
+            <a:r>
+              <a:rPr lang="en-US" sz="950" dirty="0">
+                <a:solidFill>
+                  <a:srgbClr val="C0B8B0"/>
+                </a:solidFill>
+                <a:latin typeface="Segoe UI" pitchFamily="34" charset="0"/>
+                <a:ea typeface="Segoe UI" pitchFamily="34" charset="-122"/>
+                <a:cs typeface="Segoe UI" pitchFamily="34" charset="-120"/>
+              </a:rPr>
               <a:t>🌐  reihan.online</a:t>
             </a:r>
             <a:endParaRPr lang="en-US" sz="950" dirty="0"/>
@@ -2431,7 +2470,7 @@
       </p:sp>
       <p:pic>
         <p:nvPicPr>
-          <p:cNvPr id="16" name="Image 0" descr="preencoded.png">    </p:cNvPr>
+          <p:cNvPr id="17" name="Image 0" descr="preencoded.png">    </p:cNvPr>
           <p:cNvPicPr>
             <a:picLocks noChangeAspect="1"/>
           </p:cNvPicPr>
@@ -2454,7 +2493,7 @@
       </p:pic>
       <p:sp>
         <p:nvSpPr>
-          <p:cNvPr id="17" name="Text 14"/>
+          <p:cNvPr id="18" name="Text 15"/>
           <p:cNvSpPr/>
           <p:nvPr/>
         </p:nvSpPr>
@@ -2493,7 +2532,7 @@
       </p:sp>
       <p:sp>
         <p:nvSpPr>
-          <p:cNvPr id="18" name="Text 15"/>
+          <p:cNvPr id="19" name="Text 16"/>
           <p:cNvSpPr/>
           <p:nvPr/>
         </p:nvSpPr>
@@ -6362,7 +6401,7 @@
                 <a:ea typeface="Segoe UI" pitchFamily="34" charset="-122"/>
                 <a:cs typeface="Segoe UI" pitchFamily="34" charset="-120"/>
               </a:rPr>
-              <a:t>✉  Email</a:t>
+              <a:t>✈  Telegram</a:t>
             </a:r>
             <a:endParaRPr lang="en-US" sz="800" dirty="0"/>
           </a:p>
@@ -6413,7 +6452,7 @@
                   </a:extLst>
                 </a:hlinkClick>
               </a:rPr>
-              <a:t>reyhanmutakin1@gmail.com</a:t>
+              <a:t>@Rei219 (t.me/Rei219)</a:t>
             </a:r>
             <a:endParaRPr lang="en-US" sz="1000" dirty="0"/>
           </a:p>
@@ -6477,7 +6516,7 @@
                 <a:ea typeface="Segoe UI" pitchFamily="34" charset="-122"/>
                 <a:cs typeface="Segoe UI" pitchFamily="34" charset="-120"/>
               </a:rPr>
-              <a:t>📞  WhatsApp</a:t>
+              <a:t>✉  Email</a:t>
             </a:r>
             <a:endParaRPr lang="en-US" sz="800" dirty="0"/>
           </a:p>
@@ -6528,7 +6567,7 @@
                   </a:extLst>
                 </a:hlinkClick>
               </a:rPr>
-              <a:t>+62 821 1103 9958</a:t>
+              <a:t>reyhanmutakin1@gmail.com</a:t>
             </a:r>
             <a:endParaRPr lang="en-US" sz="1000" dirty="0"/>
           </a:p>
@@ -6592,7 +6631,7 @@
                 <a:ea typeface="Segoe UI" pitchFamily="34" charset="-122"/>
                 <a:cs typeface="Segoe UI" pitchFamily="34" charset="-120"/>
               </a:rPr>
-              <a:t>📍  Domisili</a:t>
+              <a:t>📞  WhatsApp</a:t>
             </a:r>
             <a:endParaRPr lang="en-US" sz="800" dirty="0"/>
           </a:p>
@@ -6600,113 +6639,7 @@
       </p:sp>
       <p:sp>
         <p:nvSpPr>
-          <p:cNvPr id="14" name="Text 12"/>
-          <p:cNvSpPr/>
-          <p:nvPr/>
-        </p:nvSpPr>
-        <p:spPr>
-          <a:xfrm>
-            <a:off x="8366760" y="3904488"/>
-            <a:ext cx="3291840" cy="502920"/>
-          </a:xfrm>
-          <a:prstGeom prst="rect">
-            <a:avLst/>
-          </a:prstGeom>
-          <a:noFill/>
-          <a:ln/>
-        </p:spPr>
-        <p:txBody>
-          <a:bodyPr wrap="square" rtlCol="0" anchor="ctr"/>
-          <a:lstStyle/>
-          <a:p>
-            <a:pPr indent="0" marL="0">
-              <a:lnSpc>
-                <a:spcPct val="120000"/>
-              </a:lnSpc>
-              <a:buNone/>
-            </a:pPr>
-            <a:r>
-              <a:rPr lang="en-US" sz="1000" dirty="0">
-                <a:solidFill>
-                  <a:srgbClr val="FFFFFF"/>
-                </a:solidFill>
-                <a:latin typeface="Segoe UI" pitchFamily="34" charset="0"/>
-                <a:ea typeface="Segoe UI" pitchFamily="34" charset="-122"/>
-                <a:cs typeface="Segoe UI" pitchFamily="34" charset="-120"/>
-              </a:rPr>
-              <a:t>Pandeglang, Banten, Indonesia</a:t>
-            </a:r>
-            <a:endParaRPr lang="en-US" sz="1000" dirty="0"/>
-          </a:p>
-        </p:txBody>
-      </p:sp>
-      <p:sp>
-        <p:nvSpPr>
-          <p:cNvPr id="15" name="Shape 13"/>
-          <p:cNvSpPr/>
-          <p:nvPr/>
-        </p:nvSpPr>
-        <p:spPr>
-          <a:xfrm>
-            <a:off x="548640" y="4892040"/>
-            <a:ext cx="3566160" cy="1097280"/>
-          </a:xfrm>
-          <a:prstGeom prst="rect">
-            <a:avLst/>
-          </a:prstGeom>
-          <a:solidFill>
-            <a:srgbClr val="1C1917"/>
-          </a:solidFill>
-          <a:ln w="12700">
-            <a:solidFill>
-              <a:srgbClr val="2D2925"/>
-            </a:solidFill>
-            <a:prstDash val="solid"/>
-          </a:ln>
-        </p:spPr>
-      </p:sp>
-      <p:sp>
-        <p:nvSpPr>
-          <p:cNvPr id="16" name="Text 14"/>
-          <p:cNvSpPr/>
-          <p:nvPr/>
-        </p:nvSpPr>
-        <p:spPr>
-          <a:xfrm>
-            <a:off x="685800" y="4983480"/>
-            <a:ext cx="3291840" cy="256032"/>
-          </a:xfrm>
-          <a:prstGeom prst="rect">
-            <a:avLst/>
-          </a:prstGeom>
-          <a:noFill/>
-          <a:ln/>
-        </p:spPr>
-        <p:txBody>
-          <a:bodyPr wrap="square" rtlCol="0" anchor="ctr"/>
-          <a:lstStyle/>
-          <a:p>
-            <a:pPr indent="0" marL="0">
-              <a:buNone/>
-            </a:pPr>
-            <a:r>
-              <a:rPr lang="en-US" sz="800" b="1" dirty="0">
-                <a:solidFill>
-                  <a:srgbClr val="E95D32"/>
-                </a:solidFill>
-                <a:latin typeface="Segoe UI" pitchFamily="34" charset="0"/>
-                <a:ea typeface="Segoe UI" pitchFamily="34" charset="-122"/>
-                <a:cs typeface="Segoe UI" pitchFamily="34" charset="-120"/>
-              </a:rPr>
-              <a:t>💼  LinkedIn</a:t>
-            </a:r>
-            <a:endParaRPr lang="en-US" sz="800" dirty="0"/>
-          </a:p>
-        </p:txBody>
-      </p:sp>
-      <p:sp>
-        <p:nvSpPr>
-          <p:cNvPr id="17" name="Text 15">
+          <p:cNvPr id="14" name="Text 12">
             <a:hlinkClick r:id="rId3" tooltip=""/>
           </p:cNvPr>
           <p:cNvSpPr/>
@@ -6714,7 +6647,7 @@
         </p:nvSpPr>
         <p:spPr>
           <a:xfrm>
-            <a:off x="685800" y="5276088"/>
+            <a:off x="8366760" y="3904488"/>
             <a:ext cx="3291840" cy="502920"/>
           </a:xfrm>
           <a:prstGeom prst="rect">
@@ -6749,7 +6682,7 @@
                   </a:extLst>
                 </a:hlinkClick>
               </a:rPr>
-              <a:t>linkedin.com/in/reihan-mutaqin-351169201</a:t>
+              <a:t>+62 821 1103 9958</a:t>
             </a:r>
             <a:endParaRPr lang="en-US" sz="1000" dirty="0"/>
           </a:p>
@@ -6757,13 +6690,13 @@
       </p:sp>
       <p:sp>
         <p:nvSpPr>
-          <p:cNvPr id="18" name="Shape 16"/>
-          <p:cNvSpPr/>
-          <p:nvPr/>
-        </p:nvSpPr>
-        <p:spPr>
-          <a:xfrm>
-            <a:off x="4389120" y="4892040"/>
+          <p:cNvPr id="15" name="Shape 13"/>
+          <p:cNvSpPr/>
+          <p:nvPr/>
+        </p:nvSpPr>
+        <p:spPr>
+          <a:xfrm>
+            <a:off x="548640" y="4892040"/>
             <a:ext cx="3566160" cy="1097280"/>
           </a:xfrm>
           <a:prstGeom prst="rect">
@@ -6782,13 +6715,13 @@
       </p:sp>
       <p:sp>
         <p:nvSpPr>
-          <p:cNvPr id="19" name="Text 17"/>
-          <p:cNvSpPr/>
-          <p:nvPr/>
-        </p:nvSpPr>
-        <p:spPr>
-          <a:xfrm>
-            <a:off x="4526280" y="4983480"/>
+          <p:cNvPr id="16" name="Text 14"/>
+          <p:cNvSpPr/>
+          <p:nvPr/>
+        </p:nvSpPr>
+        <p:spPr>
+          <a:xfrm>
+            <a:off x="685800" y="4983480"/>
             <a:ext cx="3291840" cy="256032"/>
           </a:xfrm>
           <a:prstGeom prst="rect">
@@ -6813,7 +6746,7 @@
                 <a:ea typeface="Segoe UI" pitchFamily="34" charset="-122"/>
                 <a:cs typeface="Segoe UI" pitchFamily="34" charset="-120"/>
               </a:rPr>
-              <a:t>🐙  GitHub</a:t>
+              <a:t>💼  LinkedIn</a:t>
             </a:r>
             <a:endParaRPr lang="en-US" sz="800" dirty="0"/>
           </a:p>
@@ -6821,7 +6754,7 @@
       </p:sp>
       <p:sp>
         <p:nvSpPr>
-          <p:cNvPr id="20" name="Text 18">
+          <p:cNvPr id="17" name="Text 15">
             <a:hlinkClick r:id="rId4" tooltip=""/>
           </p:cNvPr>
           <p:cNvSpPr/>
@@ -6829,7 +6762,7 @@
         </p:nvSpPr>
         <p:spPr>
           <a:xfrm>
-            <a:off x="4526280" y="5276088"/>
+            <a:off x="685800" y="5276088"/>
             <a:ext cx="3291840" cy="502920"/>
           </a:xfrm>
           <a:prstGeom prst="rect">
@@ -6864,7 +6797,7 @@
                   </a:extLst>
                 </a:hlinkClick>
               </a:rPr>
-              <a:t>github.com/ReihanMutaqin</a:t>
+              <a:t>linkedin.com/in/reihan-mutaqin-351169201</a:t>
             </a:r>
             <a:endParaRPr lang="en-US" sz="1000" dirty="0"/>
           </a:p>
@@ -6872,13 +6805,13 @@
       </p:sp>
       <p:sp>
         <p:nvSpPr>
-          <p:cNvPr id="21" name="Shape 19"/>
-          <p:cNvSpPr/>
-          <p:nvPr/>
-        </p:nvSpPr>
-        <p:spPr>
-          <a:xfrm>
-            <a:off x="8229600" y="4892040"/>
+          <p:cNvPr id="18" name="Shape 16"/>
+          <p:cNvSpPr/>
+          <p:nvPr/>
+        </p:nvSpPr>
+        <p:spPr>
+          <a:xfrm>
+            <a:off x="4389120" y="4892040"/>
             <a:ext cx="3566160" cy="1097280"/>
           </a:xfrm>
           <a:prstGeom prst="rect">
@@ -6897,13 +6830,13 @@
       </p:sp>
       <p:sp>
         <p:nvSpPr>
-          <p:cNvPr id="22" name="Text 20"/>
-          <p:cNvSpPr/>
-          <p:nvPr/>
-        </p:nvSpPr>
-        <p:spPr>
-          <a:xfrm>
-            <a:off x="8366760" y="4983480"/>
+          <p:cNvPr id="19" name="Text 17"/>
+          <p:cNvSpPr/>
+          <p:nvPr/>
+        </p:nvSpPr>
+        <p:spPr>
+          <a:xfrm>
+            <a:off x="4526280" y="4983480"/>
             <a:ext cx="3291840" cy="256032"/>
           </a:xfrm>
           <a:prstGeom prst="rect">
@@ -6928,7 +6861,7 @@
                 <a:ea typeface="Segoe UI" pitchFamily="34" charset="-122"/>
                 <a:cs typeface="Segoe UI" pitchFamily="34" charset="-120"/>
               </a:rPr>
-              <a:t>🌐  Website</a:t>
+              <a:t>🐙  GitHub</a:t>
             </a:r>
             <a:endParaRPr lang="en-US" sz="800" dirty="0"/>
           </a:p>
@@ -6936,7 +6869,7 @@
       </p:sp>
       <p:sp>
         <p:nvSpPr>
-          <p:cNvPr id="23" name="Text 21">
+          <p:cNvPr id="20" name="Text 18">
             <a:hlinkClick r:id="rId5" tooltip=""/>
           </p:cNvPr>
           <p:cNvSpPr/>
@@ -6944,7 +6877,7 @@
         </p:nvSpPr>
         <p:spPr>
           <a:xfrm>
-            <a:off x="8366760" y="5276088"/>
+            <a:off x="4526280" y="5276088"/>
             <a:ext cx="3291840" cy="502920"/>
           </a:xfrm>
           <a:prstGeom prst="rect">
@@ -6972,6 +6905,121 @@
                 <a:ea typeface="Segoe UI" pitchFamily="34" charset="-122"/>
                 <a:cs typeface="Segoe UI" pitchFamily="34" charset="-120"/>
                 <a:hlinkClick r:id="rId5" invalidUrl="" action="" tgtFrame="" tooltip="" history="1" highlightClick="0" endSnd="0">
+                  <a:extLst>
+                    <a:ext uri="{A12FA001-AC4F-418D-AE19-62706E023703}">
+                      <ahyp:hlinkClr xmlns:ahyp="http://schemas.microsoft.com/office/drawing/2018/hyperlinkcolor" val="tx"/>
+                    </a:ext>
+                  </a:extLst>
+                </a:hlinkClick>
+              </a:rPr>
+              <a:t>github.com/ReihanMutaqin</a:t>
+            </a:r>
+            <a:endParaRPr lang="en-US" sz="1000" dirty="0"/>
+          </a:p>
+        </p:txBody>
+      </p:sp>
+      <p:sp>
+        <p:nvSpPr>
+          <p:cNvPr id="21" name="Shape 19"/>
+          <p:cNvSpPr/>
+          <p:nvPr/>
+        </p:nvSpPr>
+        <p:spPr>
+          <a:xfrm>
+            <a:off x="8229600" y="4892040"/>
+            <a:ext cx="3566160" cy="1097280"/>
+          </a:xfrm>
+          <a:prstGeom prst="rect">
+            <a:avLst/>
+          </a:prstGeom>
+          <a:solidFill>
+            <a:srgbClr val="1C1917"/>
+          </a:solidFill>
+          <a:ln w="12700">
+            <a:solidFill>
+              <a:srgbClr val="2D2925"/>
+            </a:solidFill>
+            <a:prstDash val="solid"/>
+          </a:ln>
+        </p:spPr>
+      </p:sp>
+      <p:sp>
+        <p:nvSpPr>
+          <p:cNvPr id="22" name="Text 20"/>
+          <p:cNvSpPr/>
+          <p:nvPr/>
+        </p:nvSpPr>
+        <p:spPr>
+          <a:xfrm>
+            <a:off x="8366760" y="4983480"/>
+            <a:ext cx="3291840" cy="256032"/>
+          </a:xfrm>
+          <a:prstGeom prst="rect">
+            <a:avLst/>
+          </a:prstGeom>
+          <a:noFill/>
+          <a:ln/>
+        </p:spPr>
+        <p:txBody>
+          <a:bodyPr wrap="square" rtlCol="0" anchor="ctr"/>
+          <a:lstStyle/>
+          <a:p>
+            <a:pPr indent="0" marL="0">
+              <a:buNone/>
+            </a:pPr>
+            <a:r>
+              <a:rPr lang="en-US" sz="800" b="1" dirty="0">
+                <a:solidFill>
+                  <a:srgbClr val="E95D32"/>
+                </a:solidFill>
+                <a:latin typeface="Segoe UI" pitchFamily="34" charset="0"/>
+                <a:ea typeface="Segoe UI" pitchFamily="34" charset="-122"/>
+                <a:cs typeface="Segoe UI" pitchFamily="34" charset="-120"/>
+              </a:rPr>
+              <a:t>🌐  Website</a:t>
+            </a:r>
+            <a:endParaRPr lang="en-US" sz="800" dirty="0"/>
+          </a:p>
+        </p:txBody>
+      </p:sp>
+      <p:sp>
+        <p:nvSpPr>
+          <p:cNvPr id="23" name="Text 21">
+            <a:hlinkClick r:id="rId6" tooltip=""/>
+          </p:cNvPr>
+          <p:cNvSpPr/>
+          <p:nvPr/>
+        </p:nvSpPr>
+        <p:spPr>
+          <a:xfrm>
+            <a:off x="8366760" y="5276088"/>
+            <a:ext cx="3291840" cy="502920"/>
+          </a:xfrm>
+          <a:prstGeom prst="rect">
+            <a:avLst/>
+          </a:prstGeom>
+          <a:noFill/>
+          <a:ln/>
+        </p:spPr>
+        <p:txBody>
+          <a:bodyPr wrap="square" rtlCol="0" anchor="ctr"/>
+          <a:lstStyle/>
+          <a:p>
+            <a:pPr indent="0" marL="0">
+              <a:lnSpc>
+                <a:spcPct val="120000"/>
+              </a:lnSpc>
+              <a:buNone/>
+            </a:pPr>
+            <a:r>
+              <a:rPr lang="en-US" sz="1000" u="sng" dirty="0">
+                <a:solidFill>
+                  <a:srgbClr val="FFFFFF"/>
+                </a:solidFill>
+                <a:latin typeface="Segoe UI" pitchFamily="34" charset="0"/>
+                <a:ea typeface="Segoe UI" pitchFamily="34" charset="-122"/>
+                <a:cs typeface="Segoe UI" pitchFamily="34" charset="-120"/>
+                <a:hlinkClick r:id="rId6" invalidUrl="" action="" tgtFrame="" tooltip="" history="1" highlightClick="0" endSnd="0">
                   <a:extLst>
                     <a:ext uri="{A12FA001-AC4F-418D-AE19-62706E023703}">
                       <ahyp:hlinkClr xmlns:ahyp="http://schemas.microsoft.com/office/drawing/2018/hyperlinkcolor" val="tx"/>

</xml_diff>